<commit_message>
auto(analyze): portfolio PPT 2026-07-04T16:45:41Z
</commit_message>
<xml_diff>
--- a/reports/portfolio/2026-07-05.pptx
+++ b/reports/portfolio/2026-07-05.pptx
@@ -3193,7 +3193,7 @@
                   <a:srgbClr val="555555"/>
                 </a:solidFill>
               </a:rPr>
-              <a:t>분석 기간: 2026-06-29 00:00 ~ 2026-07-05 00:25</a:t>
+              <a:t>분석 기간: 2026-06-29 00:00 ~ 2026-07-05 01:05</a:t>
             </a:r>
           </a:p>
           <a:p>
@@ -3204,7 +3204,7 @@
                   <a:srgbClr val="555555"/>
                 </a:solidFill>
               </a:rPr>
-              <a:t>데이터: 총 1,734건 · 5분 해상도 · 전국 계통 기준</a:t>
+              <a:t>데이터: 총 1,742건 · 5분 해상도 · 전국 계통 기준</a:t>
             </a:r>
           </a:p>
           <a:p>
@@ -3215,7 +3215,7 @@
                   <a:srgbClr val="555555"/>
                 </a:solidFill>
               </a:rPr>
-              <a:t>생성일: 2026-07-05 00:35 KST</a:t>
+              <a:t>생성일: 2026-07-05 01:45 KST</a:t>
             </a:r>
           </a:p>
         </p:txBody>
@@ -4170,7 +4170,7 @@
                   <a:srgbClr val="555555"/>
                 </a:solidFill>
               </a:rPr>
-              <a:t>•  총 1,734건 · 144시간 분량 5분 해상도 수집·분석</a:t>
+              <a:t>•  총 1,742건 · 145시간 분량 5분 해상도 수집·분석</a:t>
             </a:r>
           </a:p>
           <a:p>
@@ -4185,7 +4185,7 @@
                   <a:srgbClr val="555555"/>
                 </a:solidFill>
               </a:rPr>
-              <a:t>•  다층 이상탐지 결과: EWMA:5건 · CUSUM:123건 · IForest:0건 · 잔차:0건 · LSTM-AE:스킵</a:t>
+              <a:t>•  다층 이상탐지 결과: EWMA:5건 · CUSUM:121건 · IForest:0건 · 잔차:0건 · LSTM-AE:스킵</a:t>
             </a:r>
           </a:p>
           <a:p>

</xml_diff>

<commit_message>
auto(analyze): portfolio PPT 2026-07-05T10:54:41Z
</commit_message>
<xml_diff>
--- a/reports/portfolio/2026-07-05.pptx
+++ b/reports/portfolio/2026-07-05.pptx
@@ -3193,7 +3193,7 @@
                   <a:srgbClr val="555555"/>
                 </a:solidFill>
               </a:rPr>
-              <a:t>분석 기간: 2026-06-29 00:00 ~ 2026-07-05 01:05</a:t>
+              <a:t>분석 기간: 2026-06-29 00:00 ~ 2026-07-05 19:40</a:t>
             </a:r>
           </a:p>
           <a:p>
@@ -3204,7 +3204,7 @@
                   <a:srgbClr val="555555"/>
                 </a:solidFill>
               </a:rPr>
-              <a:t>데이터: 총 1,742건 · 5분 해상도 · 전국 계통 기준</a:t>
+              <a:t>데이터: 총 1,965건 · 5분 해상도 · 전국 계통 기준</a:t>
             </a:r>
           </a:p>
           <a:p>
@@ -3215,7 +3215,7 @@
                   <a:srgbClr val="555555"/>
                 </a:solidFill>
               </a:rPr>
-              <a:t>생성일: 2026-07-05 10:12 KST</a:t>
+              <a:t>생성일: 2026-07-05 19:54 KST</a:t>
             </a:r>
           </a:p>
         </p:txBody>
@@ -4170,7 +4170,7 @@
                   <a:srgbClr val="555555"/>
                 </a:solidFill>
               </a:rPr>
-              <a:t>•  총 1,742건 · 145시간 분량 5분 해상도 수집·분석</a:t>
+              <a:t>•  총 1,965건 · 164시간 분량 5분 해상도 수집·분석</a:t>
             </a:r>
           </a:p>
           <a:p>
@@ -4185,7 +4185,7 @@
                   <a:srgbClr val="555555"/>
                 </a:solidFill>
               </a:rPr>
-              <a:t>•  다층 이상탐지 결과: EWMA:5건 · CUSUM:121건 · IForest:0건 · 잔차:0건 · LSTM-AE:스킵</a:t>
+              <a:t>•  다층 이상탐지 결과: EWMA:5건 · CUSUM:136건 · IForest:0건 · 잔차:0건 · LSTM-AE:스킵</a:t>
             </a:r>
           </a:p>
           <a:p>

</xml_diff>

<commit_message>
auto(analyze): portfolio PPT 2026-07-05T12:44:28Z
</commit_message>
<xml_diff>
--- a/reports/portfolio/2026-07-05.pptx
+++ b/reports/portfolio/2026-07-05.pptx
@@ -3193,7 +3193,7 @@
                   <a:srgbClr val="555555"/>
                 </a:solidFill>
               </a:rPr>
-              <a:t>분석 기간: 2026-06-29 00:00 ~ 2026-07-05 19:40</a:t>
+              <a:t>분석 기간: 2026-06-29 00:00 ~ 2026-07-05 21:35</a:t>
             </a:r>
           </a:p>
           <a:p>
@@ -3204,7 +3204,7 @@
                   <a:srgbClr val="555555"/>
                 </a:solidFill>
               </a:rPr>
-              <a:t>데이터: 총 1,965건 · 5분 해상도 · 전국 계통 기준</a:t>
+              <a:t>데이터: 총 1,988건 · 5분 해상도 · 전국 계통 기준</a:t>
             </a:r>
           </a:p>
           <a:p>
@@ -3215,7 +3215,7 @@
                   <a:srgbClr val="555555"/>
                 </a:solidFill>
               </a:rPr>
-              <a:t>생성일: 2026-07-05 19:54 KST</a:t>
+              <a:t>생성일: 2026-07-05 21:44 KST</a:t>
             </a:r>
           </a:p>
         </p:txBody>
@@ -4170,7 +4170,7 @@
                   <a:srgbClr val="555555"/>
                 </a:solidFill>
               </a:rPr>
-              <a:t>•  총 1,965건 · 164시간 분량 5분 해상도 수집·분석</a:t>
+              <a:t>•  총 1,988건 · 166시간 분량 5분 해상도 수집·분석</a:t>
             </a:r>
           </a:p>
           <a:p>

</xml_diff>

<commit_message>
auto(analyze): portfolio PPT 2026-07-05T14:21:57Z
</commit_message>
<xml_diff>
--- a/reports/portfolio/2026-07-05.pptx
+++ b/reports/portfolio/2026-07-05.pptx
@@ -3193,7 +3193,7 @@
                   <a:srgbClr val="555555"/>
                 </a:solidFill>
               </a:rPr>
-              <a:t>분석 기간: 2026-06-29 00:00 ~ 2026-07-05 21:35</a:t>
+              <a:t>분석 기간: 2026-06-29 00:00 ~ 2026-07-05 23:15</a:t>
             </a:r>
           </a:p>
           <a:p>
@@ -3204,7 +3204,7 @@
                   <a:srgbClr val="555555"/>
                 </a:solidFill>
               </a:rPr>
-              <a:t>데이터: 총 1,988건 · 5분 해상도 · 전국 계통 기준</a:t>
+              <a:t>데이터: 총 2,008건 · 5분 해상도 · 전국 계통 기준</a:t>
             </a:r>
           </a:p>
           <a:p>
@@ -3215,7 +3215,7 @@
                   <a:srgbClr val="555555"/>
                 </a:solidFill>
               </a:rPr>
-              <a:t>생성일: 2026-07-05 21:44 KST</a:t>
+              <a:t>생성일: 2026-07-05 23:21 KST</a:t>
             </a:r>
           </a:p>
         </p:txBody>
@@ -4170,7 +4170,7 @@
                   <a:srgbClr val="555555"/>
                 </a:solidFill>
               </a:rPr>
-              <a:t>•  총 1,988건 · 166시간 분량 5분 해상도 수집·분석</a:t>
+              <a:t>•  총 2,008건 · 167시간 분량 5분 해상도 수집·분석</a:t>
             </a:r>
           </a:p>
           <a:p>
@@ -4185,7 +4185,7 @@
                   <a:srgbClr val="555555"/>
                 </a:solidFill>
               </a:rPr>
-              <a:t>•  다층 이상탐지 결과: EWMA:5건 · CUSUM:136건 · IForest:0건 · 잔차:0건 · LSTM-AE:스킵</a:t>
+              <a:t>•  다층 이상탐지 결과: EWMA:5건 · CUSUM:140건 · IForest:0건 · 잔차:0건 · LSTM-AE:스킵</a:t>
             </a:r>
           </a:p>
           <a:p>

</xml_diff>